<commit_message>
Update 이심전심 assets and add ZIP slides
Co-Authored-By: Claude Opus 4.6 (1M context) <noreply@anthropic.com>
</commit_message>
<xml_diff>
--- a/public/downloads/games/telepathy/rules.pptx
+++ b/public/downloads/games/telepathy/rules.pptx
@@ -35,16 +35,12 @@
   <p:notesSz cx="6858000" cy="9144000"/>
   <p:embeddedFontLst>
     <p:embeddedFont>
-      <p:font typeface="Jua" charset="1" panose="00000000000000000000"/>
+      <p:font typeface="무궁화 고딕" charset="1" panose="02020603020101020101"/>
       <p:regular r:id="rId31"/>
     </p:embeddedFont>
     <p:embeddedFont>
-      <p:font typeface="TDTD갬성명조" charset="1" panose="02000503000000000000"/>
+      <p:font typeface="무궁화 고딕 Bold" charset="1" panose="02020603020101020101"/>
       <p:regular r:id="rId32"/>
-    </p:embeddedFont>
-    <p:embeddedFont>
-      <p:font typeface="TDTD가온" charset="1" panose="02000503000000000000"/>
-      <p:regular r:id="rId33"/>
     </p:embeddedFont>
   </p:embeddedFontLst>
   <p:defaultTextStyle>
@@ -3162,8 +3158,8 @@
         </p:nvSpPr>
         <p:spPr>
           <a:xfrm rot="0">
-            <a:off x="1028700" y="3892867"/>
-            <a:ext cx="15555091" cy="2200275"/>
+            <a:off x="1028700" y="4178617"/>
+            <a:ext cx="15555091" cy="1914525"/>
           </a:xfrm>
           <a:prstGeom prst="rect">
             <a:avLst/>
@@ -3185,10 +3181,10 @@
                 <a:solidFill>
                   <a:srgbClr val="FFFAEF"/>
                 </a:solidFill>
-                <a:latin typeface="Jua"/>
-                <a:ea typeface="Jua"/>
-                <a:cs typeface="Jua"/>
-                <a:sym typeface="Jua"/>
+                <a:latin typeface="무궁화 고딕"/>
+                <a:ea typeface="무궁화 고딕"/>
+                <a:cs typeface="무궁화 고딕"/>
+                <a:sym typeface="무궁화 고딕"/>
               </a:rPr>
               <a:t>이심전심</a:t>
             </a:r>
@@ -3203,8 +3199,8 @@
         </p:nvSpPr>
         <p:spPr>
           <a:xfrm rot="0">
-            <a:off x="15264803" y="9812655"/>
-            <a:ext cx="2637975" cy="474345"/>
+            <a:off x="14522856" y="9822180"/>
+            <a:ext cx="3379923" cy="464820"/>
           </a:xfrm>
           <a:prstGeom prst="rect">
             <a:avLst/>
@@ -3229,10 +3225,10 @@
                 <a:solidFill>
                   <a:srgbClr val="FFFFFF"/>
                 </a:solidFill>
-                <a:latin typeface="TDTD갬성명조"/>
-                <a:ea typeface="TDTD갬성명조"/>
-                <a:cs typeface="TDTD갬성명조"/>
-                <a:sym typeface="TDTD갬성명조"/>
+                <a:latin typeface="무궁화 고딕"/>
+                <a:ea typeface="무궁화 고딕"/>
+                <a:cs typeface="무궁화 고딕"/>
+                <a:sym typeface="무궁화 고딕"/>
               </a:rPr>
               <a:t>ⓒ 2026. Sunday Play</a:t>
             </a:r>
@@ -3329,8 +3325,8 @@
         </p:nvSpPr>
         <p:spPr>
           <a:xfrm rot="0">
-            <a:off x="461635" y="3152775"/>
-            <a:ext cx="17364730" cy="3514725"/>
+            <a:off x="461635" y="3609975"/>
+            <a:ext cx="17364730" cy="3057525"/>
           </a:xfrm>
           <a:prstGeom prst="rect">
             <a:avLst/>
@@ -3352,10 +3348,10 @@
                 <a:solidFill>
                   <a:srgbClr val="000000"/>
                 </a:solidFill>
-                <a:latin typeface="Jua"/>
-                <a:ea typeface="Jua"/>
-                <a:cs typeface="Jua"/>
-                <a:sym typeface="Jua"/>
+                <a:latin typeface="무궁화 고딕"/>
+                <a:ea typeface="무궁화 고딕"/>
+                <a:cs typeface="무궁화 고딕"/>
+                <a:sym typeface="무궁화 고딕"/>
               </a:rPr>
               <a:t>셀카</a:t>
             </a:r>
@@ -3452,8 +3448,8 @@
         </p:nvSpPr>
         <p:spPr>
           <a:xfrm rot="0">
-            <a:off x="461635" y="3152775"/>
-            <a:ext cx="17364730" cy="3514725"/>
+            <a:off x="461635" y="3609975"/>
+            <a:ext cx="17364730" cy="3057525"/>
           </a:xfrm>
           <a:prstGeom prst="rect">
             <a:avLst/>
@@ -3475,10 +3471,10 @@
                 <a:solidFill>
                   <a:srgbClr val="000000"/>
                 </a:solidFill>
-                <a:latin typeface="Jua"/>
-                <a:ea typeface="Jua"/>
-                <a:cs typeface="Jua"/>
-                <a:sym typeface="Jua"/>
+                <a:latin typeface="무궁화 고딕"/>
+                <a:ea typeface="무궁화 고딕"/>
+                <a:cs typeface="무궁화 고딕"/>
+                <a:sym typeface="무궁화 고딕"/>
               </a:rPr>
               <a:t>태권도</a:t>
             </a:r>
@@ -3575,8 +3571,8 @@
         </p:nvSpPr>
         <p:spPr>
           <a:xfrm rot="0">
-            <a:off x="461635" y="3152775"/>
-            <a:ext cx="17364730" cy="3514725"/>
+            <a:off x="461635" y="3609975"/>
+            <a:ext cx="17364730" cy="3057525"/>
           </a:xfrm>
           <a:prstGeom prst="rect">
             <a:avLst/>
@@ -3598,10 +3594,10 @@
                 <a:solidFill>
                   <a:srgbClr val="000000"/>
                 </a:solidFill>
-                <a:latin typeface="Jua"/>
-                <a:ea typeface="Jua"/>
-                <a:cs typeface="Jua"/>
-                <a:sym typeface="Jua"/>
+                <a:latin typeface="무궁화 고딕"/>
+                <a:ea typeface="무궁화 고딕"/>
+                <a:cs typeface="무궁화 고딕"/>
+                <a:sym typeface="무궁화 고딕"/>
               </a:rPr>
               <a:t>낚시</a:t>
             </a:r>
@@ -3698,8 +3694,8 @@
         </p:nvSpPr>
         <p:spPr>
           <a:xfrm rot="0">
-            <a:off x="461635" y="3152775"/>
-            <a:ext cx="17364730" cy="3514725"/>
+            <a:off x="461635" y="3609975"/>
+            <a:ext cx="17364730" cy="3057525"/>
           </a:xfrm>
           <a:prstGeom prst="rect">
             <a:avLst/>
@@ -3721,10 +3717,10 @@
                 <a:solidFill>
                   <a:srgbClr val="000000"/>
                 </a:solidFill>
-                <a:latin typeface="Jua"/>
-                <a:ea typeface="Jua"/>
-                <a:cs typeface="Jua"/>
-                <a:sym typeface="Jua"/>
+                <a:latin typeface="무궁화 고딕"/>
+                <a:ea typeface="무궁화 고딕"/>
+                <a:cs typeface="무궁화 고딕"/>
+                <a:sym typeface="무궁화 고딕"/>
               </a:rPr>
               <a:t>겨울</a:t>
             </a:r>
@@ -3821,8 +3817,8 @@
         </p:nvSpPr>
         <p:spPr>
           <a:xfrm rot="0">
-            <a:off x="461635" y="3152775"/>
-            <a:ext cx="17364730" cy="3514725"/>
+            <a:off x="461635" y="3609975"/>
+            <a:ext cx="17364730" cy="3057525"/>
           </a:xfrm>
           <a:prstGeom prst="rect">
             <a:avLst/>
@@ -3844,10 +3840,10 @@
                 <a:solidFill>
                   <a:srgbClr val="000000"/>
                 </a:solidFill>
-                <a:latin typeface="Jua"/>
-                <a:ea typeface="Jua"/>
-                <a:cs typeface="Jua"/>
-                <a:sym typeface="Jua"/>
+                <a:latin typeface="무궁화 고딕"/>
+                <a:ea typeface="무궁화 고딕"/>
+                <a:cs typeface="무궁화 고딕"/>
+                <a:sym typeface="무궁화 고딕"/>
               </a:rPr>
               <a:t>양궁</a:t>
             </a:r>
@@ -3944,8 +3940,8 @@
         </p:nvSpPr>
         <p:spPr>
           <a:xfrm rot="0">
-            <a:off x="461635" y="3152775"/>
-            <a:ext cx="17364730" cy="3514725"/>
+            <a:off x="461635" y="3609975"/>
+            <a:ext cx="17364730" cy="3057525"/>
           </a:xfrm>
           <a:prstGeom prst="rect">
             <a:avLst/>
@@ -3967,10 +3963,10 @@
                 <a:solidFill>
                   <a:srgbClr val="000000"/>
                 </a:solidFill>
-                <a:latin typeface="Jua"/>
-                <a:ea typeface="Jua"/>
-                <a:cs typeface="Jua"/>
-                <a:sym typeface="Jua"/>
+                <a:latin typeface="무궁화 고딕"/>
+                <a:ea typeface="무궁화 고딕"/>
+                <a:cs typeface="무궁화 고딕"/>
+                <a:sym typeface="무궁화 고딕"/>
               </a:rPr>
               <a:t>기도</a:t>
             </a:r>
@@ -4067,8 +4063,8 @@
         </p:nvSpPr>
         <p:spPr>
           <a:xfrm rot="0">
-            <a:off x="461635" y="3152775"/>
-            <a:ext cx="17364730" cy="3514725"/>
+            <a:off x="461635" y="3609975"/>
+            <a:ext cx="17364730" cy="3057525"/>
           </a:xfrm>
           <a:prstGeom prst="rect">
             <a:avLst/>
@@ -4090,10 +4086,10 @@
                 <a:solidFill>
                   <a:srgbClr val="000000"/>
                 </a:solidFill>
-                <a:latin typeface="Jua"/>
-                <a:ea typeface="Jua"/>
-                <a:cs typeface="Jua"/>
-                <a:sym typeface="Jua"/>
+                <a:latin typeface="무궁화 고딕"/>
+                <a:ea typeface="무궁화 고딕"/>
+                <a:cs typeface="무궁화 고딕"/>
+                <a:sym typeface="무궁화 고딕"/>
               </a:rPr>
               <a:t>원숭이</a:t>
             </a:r>
@@ -4190,8 +4186,8 @@
         </p:nvSpPr>
         <p:spPr>
           <a:xfrm rot="0">
-            <a:off x="461635" y="3152775"/>
-            <a:ext cx="17364730" cy="3514725"/>
+            <a:off x="461635" y="3609975"/>
+            <a:ext cx="17364730" cy="3057525"/>
           </a:xfrm>
           <a:prstGeom prst="rect">
             <a:avLst/>
@@ -4213,10 +4209,10 @@
                 <a:solidFill>
                   <a:srgbClr val="000000"/>
                 </a:solidFill>
-                <a:latin typeface="Jua"/>
-                <a:ea typeface="Jua"/>
-                <a:cs typeface="Jua"/>
-                <a:sym typeface="Jua"/>
+                <a:latin typeface="무궁화 고딕"/>
+                <a:ea typeface="무궁화 고딕"/>
+                <a:cs typeface="무궁화 고딕"/>
+                <a:sym typeface="무궁화 고딕"/>
               </a:rPr>
               <a:t>노래</a:t>
             </a:r>
@@ -4313,8 +4309,8 @@
         </p:nvSpPr>
         <p:spPr>
           <a:xfrm rot="0">
-            <a:off x="461635" y="3152775"/>
-            <a:ext cx="17364730" cy="3514725"/>
+            <a:off x="461635" y="3609975"/>
+            <a:ext cx="17364730" cy="3057525"/>
           </a:xfrm>
           <a:prstGeom prst="rect">
             <a:avLst/>
@@ -4336,10 +4332,10 @@
                 <a:solidFill>
                   <a:srgbClr val="000000"/>
                 </a:solidFill>
-                <a:latin typeface="Jua"/>
-                <a:ea typeface="Jua"/>
-                <a:cs typeface="Jua"/>
-                <a:sym typeface="Jua"/>
+                <a:latin typeface="무궁화 고딕"/>
+                <a:ea typeface="무궁화 고딕"/>
+                <a:cs typeface="무궁화 고딕"/>
+                <a:sym typeface="무궁화 고딕"/>
               </a:rPr>
               <a:t>축구</a:t>
             </a:r>
@@ -4436,8 +4432,8 @@
         </p:nvSpPr>
         <p:spPr>
           <a:xfrm rot="0">
-            <a:off x="461635" y="3152775"/>
-            <a:ext cx="17364730" cy="3514725"/>
+            <a:off x="461635" y="3609975"/>
+            <a:ext cx="17364730" cy="3057525"/>
           </a:xfrm>
           <a:prstGeom prst="rect">
             <a:avLst/>
@@ -4459,10 +4455,10 @@
                 <a:solidFill>
                   <a:srgbClr val="000000"/>
                 </a:solidFill>
-                <a:latin typeface="Jua"/>
-                <a:ea typeface="Jua"/>
-                <a:cs typeface="Jua"/>
-                <a:sym typeface="Jua"/>
+                <a:latin typeface="무궁화 고딕"/>
+                <a:ea typeface="무궁화 고딕"/>
+                <a:cs typeface="무궁화 고딕"/>
+                <a:sym typeface="무궁화 고딕"/>
               </a:rPr>
               <a:t>호랑이</a:t>
             </a:r>
@@ -4611,8 +4607,8 @@
         </p:nvSpPr>
         <p:spPr>
           <a:xfrm rot="0">
-            <a:off x="11392761" y="600705"/>
-            <a:ext cx="5362043" cy="1600200"/>
+            <a:off x="11392761" y="819780"/>
+            <a:ext cx="5362043" cy="1381125"/>
           </a:xfrm>
           <a:prstGeom prst="rect">
             <a:avLst/>
@@ -4634,10 +4630,10 @@
                 <a:solidFill>
                   <a:srgbClr val="FFFAEF"/>
                 </a:solidFill>
-                <a:latin typeface="Jua"/>
-                <a:ea typeface="Jua"/>
-                <a:cs typeface="Jua"/>
-                <a:sym typeface="Jua"/>
+                <a:latin typeface="무궁화 고딕"/>
+                <a:ea typeface="무궁화 고딕"/>
+                <a:cs typeface="무궁화 고딕"/>
+                <a:sym typeface="무궁화 고딕"/>
               </a:rPr>
               <a:t>규칙</a:t>
             </a:r>
@@ -4653,9 +4649,9 @@
         <p:grpSpPr>
           <a:xfrm rot="0">
             <a:off x="309172" y="535073"/>
-            <a:ext cx="6944841" cy="2573620"/>
+            <a:ext cx="6944841" cy="2406534"/>
             <a:chOff x="0" y="0"/>
-            <a:chExt cx="9259787" cy="3431493"/>
+            <a:chExt cx="9259787" cy="3208711"/>
           </a:xfrm>
         </p:grpSpPr>
         <p:sp>
@@ -4666,8 +4662,8 @@
           </p:nvSpPr>
           <p:spPr>
             <a:xfrm rot="0">
-              <a:off x="0" y="1380584"/>
-              <a:ext cx="9259787" cy="2050910"/>
+              <a:off x="0" y="1388378"/>
+              <a:ext cx="9259787" cy="1820333"/>
             </a:xfrm>
             <a:prstGeom prst="rect">
               <a:avLst/>
@@ -4681,18 +4677,18 @@
             <a:p>
               <a:pPr algn="l">
                 <a:lnSpc>
-                  <a:spcPts val="6273"/>
+                  <a:spcPts val="5599"/>
                 </a:lnSpc>
               </a:pPr>
               <a:r>
-                <a:rPr lang="en-US" sz="4480">
+                <a:rPr lang="en-US" sz="3999">
                   <a:solidFill>
                     <a:srgbClr val="FFFAEF"/>
                   </a:solidFill>
-                  <a:latin typeface="TDTD가온"/>
-                  <a:ea typeface="TDTD가온"/>
-                  <a:cs typeface="TDTD가온"/>
-                  <a:sym typeface="TDTD가온"/>
+                  <a:latin typeface="무궁화 고딕"/>
+                  <a:ea typeface="무궁화 고딕"/>
+                  <a:cs typeface="무궁화 고딕"/>
+                  <a:sym typeface="무궁화 고딕"/>
                 </a:rPr>
                 <a:t>진행자가 제시어를 말합니다.</a:t>
               </a:r>
@@ -4700,18 +4696,18 @@
             <a:p>
               <a:pPr algn="l">
                 <a:lnSpc>
-                  <a:spcPts val="6273"/>
+                  <a:spcPts val="5599"/>
                 </a:lnSpc>
               </a:pPr>
               <a:r>
-                <a:rPr lang="en-US" sz="4480">
+                <a:rPr lang="en-US" sz="3999">
                   <a:solidFill>
                     <a:srgbClr val="FFFAEF"/>
                   </a:solidFill>
-                  <a:latin typeface="TDTD가온"/>
-                  <a:ea typeface="TDTD가온"/>
-                  <a:cs typeface="TDTD가온"/>
-                  <a:sym typeface="TDTD가온"/>
+                  <a:latin typeface="무궁화 고딕"/>
+                  <a:ea typeface="무궁화 고딕"/>
+                  <a:cs typeface="무궁화 고딕"/>
+                  <a:sym typeface="무궁화 고딕"/>
                 </a:rPr>
                 <a:t>팀원끼리 상의는 금지!</a:t>
               </a:r>
@@ -4726,8 +4722,8 @@
           </p:nvSpPr>
           <p:spPr>
             <a:xfrm rot="0">
-              <a:off x="0" y="-171450"/>
-              <a:ext cx="6217692" cy="1169217"/>
+              <a:off x="0" y="-66675"/>
+              <a:ext cx="6217692" cy="1062712"/>
             </a:xfrm>
             <a:prstGeom prst="rect">
               <a:avLst/>
@@ -4749,10 +4745,10 @@
                   <a:solidFill>
                     <a:srgbClr val="FFFAEF"/>
                   </a:solidFill>
-                  <a:latin typeface="Jua"/>
-                  <a:ea typeface="Jua"/>
-                  <a:cs typeface="Jua"/>
-                  <a:sym typeface="Jua"/>
+                  <a:latin typeface="무궁화 고딕 Bold"/>
+                  <a:ea typeface="무궁화 고딕 Bold"/>
+                  <a:cs typeface="무궁화 고딕 Bold"/>
+                  <a:sym typeface="무궁화 고딕 Bold"/>
                 </a:rPr>
                 <a:t>STEP 1.</a:t>
               </a:r>
@@ -4769,9 +4765,9 @@
         <p:grpSpPr>
           <a:xfrm rot="0">
             <a:off x="9639721" y="7511261"/>
-            <a:ext cx="8487123" cy="2574122"/>
+            <a:ext cx="8487123" cy="2367152"/>
             <a:chOff x="0" y="0"/>
-            <a:chExt cx="11316164" cy="3432162"/>
+            <a:chExt cx="11316164" cy="3156203"/>
           </a:xfrm>
         </p:grpSpPr>
         <p:sp>
@@ -4782,8 +4778,8 @@
           </p:nvSpPr>
           <p:spPr>
             <a:xfrm rot="0">
-              <a:off x="0" y="1377534"/>
-              <a:ext cx="11143161" cy="2054628"/>
+              <a:off x="0" y="1373758"/>
+              <a:ext cx="11143161" cy="1782445"/>
             </a:xfrm>
             <a:prstGeom prst="rect">
               <a:avLst/>
@@ -4797,18 +4793,18 @@
             <a:p>
               <a:pPr algn="l">
                 <a:lnSpc>
-                  <a:spcPts val="6284"/>
+                  <a:spcPts val="5460"/>
                 </a:lnSpc>
               </a:pPr>
               <a:r>
-                <a:rPr lang="en-US" sz="4489">
+                <a:rPr lang="en-US" sz="3900">
                   <a:solidFill>
                     <a:srgbClr val="FFFAEF"/>
                   </a:solidFill>
-                  <a:latin typeface="TDTD가온"/>
-                  <a:ea typeface="TDTD가온"/>
-                  <a:cs typeface="TDTD가온"/>
-                  <a:sym typeface="TDTD가온"/>
+                  <a:latin typeface="무궁화 고딕"/>
+                  <a:ea typeface="무궁화 고딕"/>
+                  <a:cs typeface="무궁화 고딕"/>
+                  <a:sym typeface="무궁화 고딕"/>
                 </a:rPr>
                 <a:t>같은 동작을 한 팀원이 많을수록 높은 점수! 가장 많은 점수를 얻은 팀이 우승!</a:t>
               </a:r>
@@ -4823,8 +4819,8 @@
           </p:nvSpPr>
           <p:spPr>
             <a:xfrm rot="0">
-              <a:off x="0" y="-171450"/>
-              <a:ext cx="11316164" cy="1171105"/>
+              <a:off x="0" y="-57150"/>
+              <a:ext cx="11316164" cy="1053029"/>
             </a:xfrm>
             <a:prstGeom prst="rect">
               <a:avLst/>
@@ -4846,10 +4842,10 @@
                   <a:solidFill>
                     <a:srgbClr val="FFFAEF"/>
                   </a:solidFill>
-                  <a:latin typeface="Jua"/>
-                  <a:ea typeface="Jua"/>
-                  <a:cs typeface="Jua"/>
-                  <a:sym typeface="Jua"/>
+                  <a:latin typeface="무궁화 고딕 Bold"/>
+                  <a:ea typeface="무궁화 고딕 Bold"/>
+                  <a:cs typeface="무궁화 고딕 Bold"/>
+                  <a:sym typeface="무궁화 고딕 Bold"/>
                 </a:rPr>
                 <a:t>STEP 3.</a:t>
               </a:r>
@@ -4866,9 +4862,9 @@
         <p:grpSpPr>
           <a:xfrm rot="0">
             <a:off x="5619580" y="3858476"/>
-            <a:ext cx="5484735" cy="2570047"/>
+            <a:ext cx="5484735" cy="2402261"/>
             <a:chOff x="0" y="0"/>
-            <a:chExt cx="7312980" cy="3426730"/>
+            <a:chExt cx="7312980" cy="3203015"/>
           </a:xfrm>
         </p:grpSpPr>
         <p:sp>
@@ -4879,8 +4875,8 @@
           </p:nvSpPr>
           <p:spPr>
             <a:xfrm rot="0">
-              <a:off x="0" y="1375218"/>
-              <a:ext cx="7312980" cy="2051512"/>
+              <a:off x="0" y="1382681"/>
+              <a:ext cx="7312980" cy="1820333"/>
             </a:xfrm>
             <a:prstGeom prst="rect">
               <a:avLst/>
@@ -4894,18 +4890,18 @@
             <a:p>
               <a:pPr algn="l">
                 <a:lnSpc>
-                  <a:spcPts val="6275"/>
+                  <a:spcPts val="5599"/>
                 </a:lnSpc>
               </a:pPr>
               <a:r>
-                <a:rPr lang="en-US" sz="4482">
+                <a:rPr lang="en-US" sz="3999">
                   <a:solidFill>
                     <a:srgbClr val="FFFAEF"/>
                   </a:solidFill>
-                  <a:latin typeface="TDTD가온"/>
-                  <a:ea typeface="TDTD가온"/>
-                  <a:cs typeface="TDTD가온"/>
-                  <a:sym typeface="TDTD가온"/>
+                  <a:latin typeface="무궁화 고딕"/>
+                  <a:ea typeface="무궁화 고딕"/>
+                  <a:cs typeface="무궁화 고딕"/>
+                  <a:sym typeface="무궁화 고딕"/>
                 </a:rPr>
                 <a:t>'하나, 둘, 셋' 구호에 맞춰</a:t>
               </a:r>
@@ -4913,18 +4909,18 @@
             <a:p>
               <a:pPr algn="l">
                 <a:lnSpc>
-                  <a:spcPts val="6275"/>
+                  <a:spcPts val="5599"/>
                 </a:lnSpc>
               </a:pPr>
               <a:r>
-                <a:rPr lang="en-US" sz="4482">
+                <a:rPr lang="en-US" sz="3999">
                   <a:solidFill>
                     <a:srgbClr val="FFFAEF"/>
                   </a:solidFill>
-                  <a:latin typeface="TDTD가온"/>
-                  <a:ea typeface="TDTD가온"/>
-                  <a:cs typeface="TDTD가온"/>
-                  <a:sym typeface="TDTD가온"/>
+                  <a:latin typeface="무궁화 고딕"/>
+                  <a:ea typeface="무궁화 고딕"/>
+                  <a:cs typeface="무궁화 고딕"/>
+                  <a:sym typeface="무궁화 고딕"/>
                 </a:rPr>
                 <a:t>동시에 동작하세요!</a:t>
               </a:r>
@@ -4939,8 +4935,8 @@
           </p:nvSpPr>
           <p:spPr>
             <a:xfrm rot="0">
-              <a:off x="0" y="-171450"/>
-              <a:ext cx="4508525" cy="1169523"/>
+              <a:off x="0" y="-57150"/>
+              <a:ext cx="4508525" cy="1053161"/>
             </a:xfrm>
             <a:prstGeom prst="rect">
               <a:avLst/>
@@ -4962,10 +4958,10 @@
                   <a:solidFill>
                     <a:srgbClr val="FFFAEF"/>
                   </a:solidFill>
-                  <a:latin typeface="Jua"/>
-                  <a:ea typeface="Jua"/>
-                  <a:cs typeface="Jua"/>
-                  <a:sym typeface="Jua"/>
+                  <a:latin typeface="무궁화 고딕 Bold"/>
+                  <a:ea typeface="무궁화 고딕 Bold"/>
+                  <a:cs typeface="무궁화 고딕 Bold"/>
+                  <a:sym typeface="무궁화 고딕 Bold"/>
                 </a:rPr>
                 <a:t>STEP 2.</a:t>
               </a:r>
@@ -5063,8 +5059,8 @@
         </p:nvSpPr>
         <p:spPr>
           <a:xfrm rot="0">
-            <a:off x="461635" y="3152775"/>
-            <a:ext cx="17364730" cy="3514725"/>
+            <a:off x="461635" y="3609975"/>
+            <a:ext cx="17364730" cy="3057525"/>
           </a:xfrm>
           <a:prstGeom prst="rect">
             <a:avLst/>
@@ -5086,10 +5082,10 @@
                 <a:solidFill>
                   <a:srgbClr val="000000"/>
                 </a:solidFill>
-                <a:latin typeface="Jua"/>
-                <a:ea typeface="Jua"/>
-                <a:cs typeface="Jua"/>
-                <a:sym typeface="Jua"/>
+                <a:latin typeface="무궁화 고딕"/>
+                <a:ea typeface="무궁화 고딕"/>
+                <a:cs typeface="무궁화 고딕"/>
+                <a:sym typeface="무궁화 고딕"/>
               </a:rPr>
               <a:t>요리</a:t>
             </a:r>
@@ -5186,8 +5182,8 @@
         </p:nvSpPr>
         <p:spPr>
           <a:xfrm rot="0">
-            <a:off x="461635" y="3152775"/>
-            <a:ext cx="17364730" cy="3514725"/>
+            <a:off x="461635" y="3609975"/>
+            <a:ext cx="17364730" cy="3057525"/>
           </a:xfrm>
           <a:prstGeom prst="rect">
             <a:avLst/>
@@ -5209,10 +5205,10 @@
                 <a:solidFill>
                   <a:srgbClr val="000000"/>
                 </a:solidFill>
-                <a:latin typeface="Jua"/>
-                <a:ea typeface="Jua"/>
-                <a:cs typeface="Jua"/>
-                <a:sym typeface="Jua"/>
+                <a:latin typeface="무궁화 고딕"/>
+                <a:ea typeface="무궁화 고딕"/>
+                <a:cs typeface="무궁화 고딕"/>
+                <a:sym typeface="무궁화 고딕"/>
               </a:rPr>
               <a:t>헬스</a:t>
             </a:r>
@@ -5309,8 +5305,8 @@
         </p:nvSpPr>
         <p:spPr>
           <a:xfrm rot="0">
-            <a:off x="461635" y="3152775"/>
-            <a:ext cx="17364730" cy="3514725"/>
+            <a:off x="461635" y="3609975"/>
+            <a:ext cx="17364730" cy="3057525"/>
           </a:xfrm>
           <a:prstGeom prst="rect">
             <a:avLst/>
@@ -5332,10 +5328,10 @@
                 <a:solidFill>
                   <a:srgbClr val="000000"/>
                 </a:solidFill>
-                <a:latin typeface="Jua"/>
-                <a:ea typeface="Jua"/>
-                <a:cs typeface="Jua"/>
-                <a:sym typeface="Jua"/>
+                <a:latin typeface="무궁화 고딕"/>
+                <a:ea typeface="무궁화 고딕"/>
+                <a:cs typeface="무궁화 고딕"/>
+                <a:sym typeface="무궁화 고딕"/>
               </a:rPr>
               <a:t>운전</a:t>
             </a:r>
@@ -5432,8 +5428,8 @@
         </p:nvSpPr>
         <p:spPr>
           <a:xfrm rot="0">
-            <a:off x="461635" y="3152775"/>
-            <a:ext cx="17364730" cy="3514725"/>
+            <a:off x="461635" y="3609975"/>
+            <a:ext cx="17364730" cy="3057525"/>
           </a:xfrm>
           <a:prstGeom prst="rect">
             <a:avLst/>
@@ -5455,10 +5451,10 @@
                 <a:solidFill>
                   <a:srgbClr val="000000"/>
                 </a:solidFill>
-                <a:latin typeface="Jua"/>
-                <a:ea typeface="Jua"/>
-                <a:cs typeface="Jua"/>
-                <a:sym typeface="Jua"/>
+                <a:latin typeface="무궁화 고딕"/>
+                <a:ea typeface="무궁화 고딕"/>
+                <a:cs typeface="무궁화 고딕"/>
+                <a:sym typeface="무궁화 고딕"/>
               </a:rPr>
               <a:t>잠</a:t>
             </a:r>
@@ -5555,8 +5551,8 @@
         </p:nvSpPr>
         <p:spPr>
           <a:xfrm rot="0">
-            <a:off x="461635" y="3152775"/>
-            <a:ext cx="17364730" cy="3514725"/>
+            <a:off x="461635" y="3609975"/>
+            <a:ext cx="17364730" cy="3057525"/>
           </a:xfrm>
           <a:prstGeom prst="rect">
             <a:avLst/>
@@ -5578,10 +5574,10 @@
                 <a:solidFill>
                   <a:srgbClr val="000000"/>
                 </a:solidFill>
-                <a:latin typeface="Jua"/>
-                <a:ea typeface="Jua"/>
-                <a:cs typeface="Jua"/>
-                <a:sym typeface="Jua"/>
+                <a:latin typeface="무궁화 고딕"/>
+                <a:ea typeface="무궁화 고딕"/>
+                <a:cs typeface="무궁화 고딕"/>
+                <a:sym typeface="무궁화 고딕"/>
               </a:rPr>
               <a:t>비행기</a:t>
             </a:r>
@@ -5653,8 +5649,8 @@
         </p:nvSpPr>
         <p:spPr>
           <a:xfrm rot="0">
-            <a:off x="4421807" y="3895725"/>
-            <a:ext cx="9444385" cy="2200275"/>
+            <a:off x="4421807" y="4181475"/>
+            <a:ext cx="9444385" cy="1914525"/>
           </a:xfrm>
           <a:prstGeom prst="rect">
             <a:avLst/>
@@ -5676,10 +5672,10 @@
                 <a:solidFill>
                   <a:srgbClr val="000000"/>
                 </a:solidFill>
-                <a:latin typeface="Jua"/>
-                <a:ea typeface="Jua"/>
-                <a:cs typeface="Jua"/>
-                <a:sym typeface="Jua"/>
+                <a:latin typeface="무궁화 고딕"/>
+                <a:ea typeface="무궁화 고딕"/>
+                <a:cs typeface="무궁화 고딕"/>
+                <a:sym typeface="무궁화 고딕"/>
               </a:rPr>
               <a:t>감사합니다!</a:t>
             </a:r>
@@ -5776,8 +5772,8 @@
         </p:nvSpPr>
         <p:spPr>
           <a:xfrm rot="0">
-            <a:off x="3238925" y="4092795"/>
-            <a:ext cx="11810151" cy="2200275"/>
+            <a:off x="3238925" y="4378545"/>
+            <a:ext cx="11810151" cy="1914525"/>
           </a:xfrm>
           <a:prstGeom prst="rect">
             <a:avLst/>
@@ -5799,10 +5795,10 @@
                 <a:solidFill>
                   <a:srgbClr val="000000"/>
                 </a:solidFill>
-                <a:latin typeface="Jua"/>
-                <a:ea typeface="Jua"/>
-                <a:cs typeface="Jua"/>
-                <a:sym typeface="Jua"/>
+                <a:latin typeface="무궁화 고딕"/>
+                <a:ea typeface="무궁화 고딕"/>
+                <a:cs typeface="무궁화 고딕"/>
+                <a:sym typeface="무궁화 고딕"/>
               </a:rPr>
               <a:t>팀을 나눠주세요!</a:t>
             </a:r>
@@ -5949,8 +5945,8 @@
         </p:nvSpPr>
         <p:spPr>
           <a:xfrm rot="0">
-            <a:off x="1028700" y="3892867"/>
-            <a:ext cx="15555091" cy="2200275"/>
+            <a:off x="1028700" y="4178617"/>
+            <a:ext cx="15555091" cy="1914525"/>
           </a:xfrm>
           <a:prstGeom prst="rect">
             <a:avLst/>
@@ -5972,10 +5968,10 @@
                 <a:solidFill>
                   <a:srgbClr val="FFFAEF"/>
                 </a:solidFill>
-                <a:latin typeface="Jua"/>
-                <a:ea typeface="Jua"/>
-                <a:cs typeface="Jua"/>
-                <a:sym typeface="Jua"/>
+                <a:latin typeface="무궁화 고딕"/>
+                <a:ea typeface="무궁화 고딕"/>
+                <a:cs typeface="무궁화 고딕"/>
+                <a:sym typeface="무궁화 고딕"/>
               </a:rPr>
               <a:t>이심전심</a:t>
             </a:r>
@@ -5990,8 +5986,8 @@
         </p:nvSpPr>
         <p:spPr>
           <a:xfrm rot="0">
-            <a:off x="15264803" y="9812655"/>
-            <a:ext cx="2637975" cy="474345"/>
+            <a:off x="14522856" y="9822180"/>
+            <a:ext cx="3379923" cy="464820"/>
           </a:xfrm>
           <a:prstGeom prst="rect">
             <a:avLst/>
@@ -6016,10 +6012,10 @@
                 <a:solidFill>
                   <a:srgbClr val="FFFFFF"/>
                 </a:solidFill>
-                <a:latin typeface="TDTD갬성명조"/>
-                <a:ea typeface="TDTD갬성명조"/>
-                <a:cs typeface="TDTD갬성명조"/>
-                <a:sym typeface="TDTD갬성명조"/>
+                <a:latin typeface="무궁화 고딕"/>
+                <a:ea typeface="무궁화 고딕"/>
+                <a:cs typeface="무궁화 고딕"/>
+                <a:sym typeface="무궁화 고딕"/>
               </a:rPr>
               <a:t>ⓒ 2026. Sunday Play</a:t>
             </a:r>
@@ -6116,8 +6112,8 @@
         </p:nvSpPr>
         <p:spPr>
           <a:xfrm rot="0">
-            <a:off x="461635" y="3152775"/>
-            <a:ext cx="17364730" cy="3514725"/>
+            <a:off x="461635" y="3609975"/>
+            <a:ext cx="17364730" cy="3057525"/>
           </a:xfrm>
           <a:prstGeom prst="rect">
             <a:avLst/>
@@ -6139,10 +6135,10 @@
                 <a:solidFill>
                   <a:srgbClr val="000000"/>
                 </a:solidFill>
-                <a:latin typeface="Jua"/>
-                <a:ea typeface="Jua"/>
-                <a:cs typeface="Jua"/>
-                <a:sym typeface="Jua"/>
+                <a:latin typeface="무궁화 고딕"/>
+                <a:ea typeface="무궁화 고딕"/>
+                <a:cs typeface="무궁화 고딕"/>
+                <a:sym typeface="무궁화 고딕"/>
               </a:rPr>
               <a:t>야구</a:t>
             </a:r>
@@ -6239,8 +6235,8 @@
         </p:nvSpPr>
         <p:spPr>
           <a:xfrm rot="0">
-            <a:off x="461635" y="3152775"/>
-            <a:ext cx="17364730" cy="3514725"/>
+            <a:off x="461635" y="3609975"/>
+            <a:ext cx="17364730" cy="3057525"/>
           </a:xfrm>
           <a:prstGeom prst="rect">
             <a:avLst/>
@@ -6262,10 +6258,10 @@
                 <a:solidFill>
                   <a:srgbClr val="000000"/>
                 </a:solidFill>
-                <a:latin typeface="Jua"/>
-                <a:ea typeface="Jua"/>
-                <a:cs typeface="Jua"/>
-                <a:sym typeface="Jua"/>
+                <a:latin typeface="무궁화 고딕"/>
+                <a:ea typeface="무궁화 고딕"/>
+                <a:cs typeface="무궁화 고딕"/>
+                <a:sym typeface="무궁화 고딕"/>
               </a:rPr>
               <a:t>수영</a:t>
             </a:r>
@@ -6362,8 +6358,8 @@
         </p:nvSpPr>
         <p:spPr>
           <a:xfrm rot="0">
-            <a:off x="461635" y="3152775"/>
-            <a:ext cx="17364730" cy="3514725"/>
+            <a:off x="461635" y="3609975"/>
+            <a:ext cx="17364730" cy="3057525"/>
           </a:xfrm>
           <a:prstGeom prst="rect">
             <a:avLst/>
@@ -6385,10 +6381,10 @@
                 <a:solidFill>
                   <a:srgbClr val="000000"/>
                 </a:solidFill>
-                <a:latin typeface="Jua"/>
-                <a:ea typeface="Jua"/>
-                <a:cs typeface="Jua"/>
-                <a:sym typeface="Jua"/>
+                <a:latin typeface="무궁화 고딕"/>
+                <a:ea typeface="무궁화 고딕"/>
+                <a:cs typeface="무궁화 고딕"/>
+                <a:sym typeface="무궁화 고딕"/>
               </a:rPr>
               <a:t>토끼</a:t>
             </a:r>
@@ -6485,8 +6481,8 @@
         </p:nvSpPr>
         <p:spPr>
           <a:xfrm rot="0">
-            <a:off x="461635" y="3152775"/>
-            <a:ext cx="17364730" cy="3514725"/>
+            <a:off x="461635" y="3609975"/>
+            <a:ext cx="17364730" cy="3057525"/>
           </a:xfrm>
           <a:prstGeom prst="rect">
             <a:avLst/>
@@ -6508,10 +6504,10 @@
                 <a:solidFill>
                   <a:srgbClr val="000000"/>
                 </a:solidFill>
-                <a:latin typeface="Jua"/>
-                <a:ea typeface="Jua"/>
-                <a:cs typeface="Jua"/>
-                <a:sym typeface="Jua"/>
+                <a:latin typeface="무궁화 고딕"/>
+                <a:ea typeface="무궁화 고딕"/>
+                <a:cs typeface="무궁화 고딕"/>
+                <a:sym typeface="무궁화 고딕"/>
               </a:rPr>
               <a:t>가위</a:t>
             </a:r>
@@ -6608,8 +6604,8 @@
         </p:nvSpPr>
         <p:spPr>
           <a:xfrm rot="0">
-            <a:off x="461635" y="3152775"/>
-            <a:ext cx="17364730" cy="3514725"/>
+            <a:off x="461635" y="3609975"/>
+            <a:ext cx="17364730" cy="3057525"/>
           </a:xfrm>
           <a:prstGeom prst="rect">
             <a:avLst/>
@@ -6631,10 +6627,10 @@
                 <a:solidFill>
                   <a:srgbClr val="000000"/>
                 </a:solidFill>
-                <a:latin typeface="Jua"/>
-                <a:ea typeface="Jua"/>
-                <a:cs typeface="Jua"/>
-                <a:sym typeface="Jua"/>
+                <a:latin typeface="무궁화 고딕"/>
+                <a:ea typeface="무궁화 고딕"/>
+                <a:cs typeface="무궁화 고딕"/>
+                <a:sym typeface="무궁화 고딕"/>
               </a:rPr>
               <a:t>농구</a:t>
             </a:r>

</xml_diff>